<commit_message>
updated prerequisites and hackathon instructions
</commit_message>
<xml_diff>
--- a/Day1/prerequisites.pptx
+++ b/Day1/prerequisites.pptx
@@ -5,7 +5,8 @@
     <p:sldMasterId id="2147483648" r:id="rId1"/>
   </p:sldMasterIdLst>
   <p:sldIdLst>
-    <p:sldId id="260" r:id="rId3"/>
+    <p:sldId id="261" r:id="rId3"/>
+    <p:sldId id="260" r:id="rId4"/>
   </p:sldIdLst>
   <p:sldSz cx="12192000" cy="6858000"/>
   <p:notesSz cx="6858000" cy="9144000"/>
@@ -3085,7 +3086,12 @@
             </p:custDataLst>
           </p:nvPr>
         </p:nvSpPr>
-        <p:spPr/>
+        <p:spPr>
+          <a:xfrm>
+            <a:off x="608400" y="265500"/>
+            <a:ext cx="10969200" cy="705600"/>
+          </a:xfrm>
+        </p:spPr>
         <p:txBody>
           <a:bodyPr/>
           <a:p>
@@ -3112,10 +3118,15 @@
             </p:custDataLst>
           </p:nvPr>
         </p:nvSpPr>
-        <p:spPr/>
+        <p:spPr>
+          <a:xfrm>
+            <a:off x="608330" y="970280"/>
+            <a:ext cx="10968990" cy="4936490"/>
+          </a:xfrm>
+        </p:spPr>
         <p:txBody>
           <a:bodyPr>
-            <a:normAutofit fontScale="60000"/>
+            <a:noAutofit/>
           </a:bodyPr>
           <a:p>
             <a:pPr>
@@ -3123,28 +3134,57 @@
               <a:buChar char="•"/>
             </a:pPr>
             <a:r>
-              <a:rPr lang="en-US" sz="3600"/>
-              <a:t>Locate github repo:</a:t>
-            </a:r>
-            <a:endParaRPr lang="en-US" sz="3600"/>
+              <a:rPr lang="en-US" sz="2000"/>
+              <a:t>Ensure you have a Google / Gmail Id</a:t>
+            </a:r>
+            <a:endParaRPr lang="en-US" sz="2000"/>
+          </a:p>
+          <a:p>
+            <a:pPr lvl="1">
+              <a:buFont typeface="Arial" panose="020B0604020202090204" pitchFamily="34" charset="0"/>
+              <a:buChar char="•"/>
+            </a:pPr>
+            <a:r>
+              <a:rPr lang="en-US" sz="1800"/>
+              <a:t>This will be used to sign-into Google Forms to take short surveys and quizzes</a:t>
+            </a:r>
+            <a:endParaRPr lang="en-US" sz="1800"/>
+          </a:p>
+          <a:p>
+            <a:pPr lvl="1">
+              <a:buFont typeface="Arial" panose="020B0604020202090204" pitchFamily="34" charset="0"/>
+              <a:buChar char="•"/>
+            </a:pPr>
+            <a:endParaRPr lang="en-US" sz="1800"/>
+          </a:p>
+          <a:p>
+            <a:pPr>
+              <a:buFont typeface="Arial" panose="020B0604020202090204" pitchFamily="34" charset="0"/>
+              <a:buChar char="•"/>
+            </a:pPr>
+            <a:r>
+              <a:rPr lang="en-US" sz="2000"/>
+              <a:t>Ensure you have access to github</a:t>
+            </a:r>
+            <a:endParaRPr lang="en-US" sz="2000"/>
+          </a:p>
+          <a:p>
+            <a:pPr lvl="1">
+              <a:buFont typeface="Arial" panose="020B0604020202090204" pitchFamily="34" charset="0"/>
+              <a:buChar char="•"/>
+            </a:pPr>
+            <a:r>
+              <a:rPr lang="en-US" sz="1800"/>
+              <a:t>Github Repo details will be provided during the program</a:t>
+            </a:r>
+            <a:endParaRPr lang="en-US" sz="1800"/>
           </a:p>
           <a:p>
             <a:pPr marL="457200" lvl="1" indent="0">
               <a:buFont typeface="Arial" panose="020B0604020202090204" pitchFamily="34" charset="0"/>
               <a:buNone/>
             </a:pPr>
-            <a:r>
-              <a:rPr lang="en-US" sz="3200"/>
-              <a:t>/vipar-11/workshop</a:t>
-            </a:r>
-            <a:endParaRPr lang="en-US" sz="3200"/>
-          </a:p>
-          <a:p>
-            <a:pPr marL="457200" lvl="1" indent="0">
-              <a:buFont typeface="Arial" panose="020B0604020202090204" pitchFamily="34" charset="0"/>
-              <a:buNone/>
-            </a:pPr>
-            <a:endParaRPr lang="en-US" sz="3200"/>
+            <a:endParaRPr lang="en-US" sz="1800"/>
           </a:p>
           <a:p>
             <a:pPr>
@@ -3152,10 +3192,10 @@
               <a:buChar char="•"/>
             </a:pPr>
             <a:r>
-              <a:rPr lang="en-US" sz="3600"/>
-              <a:t>Make sure you have Python3 installed</a:t>
-            </a:r>
-            <a:endParaRPr lang="en-US" sz="3600"/>
+              <a:rPr lang="en-US" sz="2000"/>
+              <a:t>Bring your laptop - Make sure you have Python3 installed</a:t>
+            </a:r>
+            <a:endParaRPr lang="en-US" sz="2000"/>
           </a:p>
           <a:p>
             <a:pPr lvl="1">
@@ -3163,17 +3203,17 @@
               <a:buChar char="•"/>
             </a:pPr>
             <a:r>
-              <a:rPr lang="en-US" sz="3200"/>
-              <a:t>You may use Online Python Notebooks</a:t>
-            </a:r>
-            <a:endParaRPr lang="en-US" sz="3200"/>
+              <a:rPr lang="en-US" sz="1800"/>
+              <a:t>Alternatively, you may use an Online Python Notebooks</a:t>
+            </a:r>
+            <a:endParaRPr lang="en-US" sz="1800"/>
           </a:p>
           <a:p>
             <a:pPr lvl="1">
               <a:buFont typeface="Arial" panose="020B0604020202090204" pitchFamily="34" charset="0"/>
               <a:buChar char="•"/>
             </a:pPr>
-            <a:endParaRPr lang="en-US" sz="3200"/>
+            <a:endParaRPr lang="en-US" sz="1800"/>
           </a:p>
           <a:p>
             <a:pPr>
@@ -3181,17 +3221,17 @@
               <a:buChar char="•"/>
             </a:pPr>
             <a:r>
-              <a:rPr lang="en-US" sz="3600"/>
+              <a:rPr lang="en-US" sz="2000"/>
               <a:t>Turn OFF Vibe Coding for the best experience</a:t>
             </a:r>
-            <a:endParaRPr lang="en-US" sz="3600"/>
+            <a:endParaRPr lang="en-US" sz="2000"/>
           </a:p>
           <a:p>
             <a:pPr>
               <a:buFont typeface="Arial" panose="020B0604020202090204" pitchFamily="34" charset="0"/>
               <a:buChar char="•"/>
             </a:pPr>
-            <a:endParaRPr lang="en-US" sz="3600"/>
+            <a:endParaRPr lang="en-US" sz="2000"/>
           </a:p>
           <a:p>
             <a:pPr>
@@ -3199,13 +3239,13 @@
               <a:buChar char="•"/>
             </a:pPr>
             <a:r>
-              <a:rPr lang="en-US" sz="3600"/>
-              <a:t>Make sure you have internet connectivity</a:t>
-            </a:r>
-            <a:endParaRPr lang="en-US" sz="3600"/>
-          </a:p>
-          <a:p>
-            <a:endParaRPr lang="en-US" sz="3600"/>
+              <a:rPr lang="en-US" sz="2000"/>
+              <a:t>Make sure you have internet connectivity on your laptop throughout the program</a:t>
+            </a:r>
+            <a:endParaRPr lang="en-US" sz="2000"/>
+          </a:p>
+          <a:p>
+            <a:endParaRPr lang="en-US" sz="2000"/>
           </a:p>
         </p:txBody>
       </p:sp>
@@ -3268,15 +3308,33 @@
                                   </p:childTnLst>
                                 </p:cTn>
                               </p:par>
+                            </p:childTnLst>
+                          </p:cTn>
+                        </p:par>
+                      </p:childTnLst>
+                    </p:cTn>
+                  </p:par>
+                  <p:par>
+                    <p:cTn id="7" fill="hold">
+                      <p:stCondLst>
+                        <p:cond delay="indefinite"/>
+                      </p:stCondLst>
+                      <p:childTnLst>
+                        <p:par>
+                          <p:cTn id="8" fill="hold">
+                            <p:stCondLst>
+                              <p:cond delay="0"/>
+                            </p:stCondLst>
+                            <p:childTnLst>
                               <p:par>
-                                <p:cTn id="7" presetID="1" presetClass="entr" presetSubtype="0" fill="hold" nodeType="withEffect">
+                                <p:cTn id="9" presetID="1" presetClass="entr" presetSubtype="0" fill="hold" nodeType="clickEffect">
                                   <p:stCondLst>
                                     <p:cond delay="0"/>
                                   </p:stCondLst>
                                   <p:childTnLst>
                                     <p:set>
                                       <p:cBhvr>
-                                        <p:cTn id="8" dur="1" fill="hold">
+                                        <p:cTn id="10" dur="1" fill="hold">
                                           <p:stCondLst>
                                             <p:cond delay="0"/>
                                           </p:stCondLst>
@@ -3306,50 +3364,19 @@
                     </p:cTn>
                   </p:par>
                   <p:par>
-                    <p:cTn id="9" fill="hold">
+                    <p:cTn id="11" fill="hold">
                       <p:stCondLst>
                         <p:cond delay="indefinite"/>
                       </p:stCondLst>
                       <p:childTnLst>
                         <p:par>
-                          <p:cTn id="10" fill="hold">
+                          <p:cTn id="12" fill="hold">
                             <p:stCondLst>
                               <p:cond delay="0"/>
                             </p:stCondLst>
                             <p:childTnLst>
                               <p:par>
-                                <p:cTn id="11" presetID="1" presetClass="entr" presetSubtype="0" fill="hold" nodeType="clickEffect">
-                                  <p:stCondLst>
-                                    <p:cond delay="0"/>
-                                  </p:stCondLst>
-                                  <p:childTnLst>
-                                    <p:set>
-                                      <p:cBhvr>
-                                        <p:cTn id="12" dur="1" fill="hold">
-                                          <p:stCondLst>
-                                            <p:cond delay="0"/>
-                                          </p:stCondLst>
-                                        </p:cTn>
-                                        <p:tgtEl>
-                                          <p:spTgt spid="3">
-                                            <p:txEl>
-                                              <p:pRg st="3" end="3"/>
-                                            </p:txEl>
-                                          </p:spTgt>
-                                        </p:tgtEl>
-                                        <p:attrNameLst>
-                                          <p:attrName>style.visibility</p:attrName>
-                                        </p:attrNameLst>
-                                      </p:cBhvr>
-                                      <p:to>
-                                        <p:strVal val="visible"/>
-                                      </p:to>
-                                    </p:set>
-                                  </p:childTnLst>
-                                </p:cTn>
-                              </p:par>
-                              <p:par>
-                                <p:cTn id="13" presetID="1" presetClass="entr" presetSubtype="0" fill="hold" nodeType="withEffect">
+                                <p:cTn id="13" presetID="1" presetClass="entr" presetSubtype="0" fill="hold" nodeType="clickEffect">
                                   <p:stCondLst>
                                     <p:cond delay="0"/>
                                   </p:stCondLst>
@@ -3364,7 +3391,7 @@
                                         <p:tgtEl>
                                           <p:spTgt spid="3">
                                             <p:txEl>
-                                              <p:pRg st="4" end="4"/>
+                                              <p:pRg st="3" end="3"/>
                                             </p:txEl>
                                           </p:spTgt>
                                         </p:tgtEl>
@@ -3413,7 +3440,7 @@
                                         <p:tgtEl>
                                           <p:spTgt spid="3">
                                             <p:txEl>
-                                              <p:pRg st="6" end="6"/>
+                                              <p:pRg st="4" end="4"/>
                                             </p:txEl>
                                           </p:spTgt>
                                         </p:tgtEl>
@@ -3462,7 +3489,136 @@
                                         <p:tgtEl>
                                           <p:spTgt spid="3">
                                             <p:txEl>
-                                              <p:pRg st="8" end="8"/>
+                                              <p:pRg st="6" end="6"/>
+                                            </p:txEl>
+                                          </p:spTgt>
+                                        </p:tgtEl>
+                                        <p:attrNameLst>
+                                          <p:attrName>style.visibility</p:attrName>
+                                        </p:attrNameLst>
+                                      </p:cBhvr>
+                                      <p:to>
+                                        <p:strVal val="visible"/>
+                                      </p:to>
+                                    </p:set>
+                                  </p:childTnLst>
+                                </p:cTn>
+                              </p:par>
+                              <p:par>
+                                <p:cTn id="23" presetID="1" presetClass="entr" presetSubtype="0" fill="hold" nodeType="withEffect">
+                                  <p:stCondLst>
+                                    <p:cond delay="0"/>
+                                  </p:stCondLst>
+                                  <p:childTnLst>
+                                    <p:set>
+                                      <p:cBhvr>
+                                        <p:cTn id="24" dur="1" fill="hold">
+                                          <p:stCondLst>
+                                            <p:cond delay="0"/>
+                                          </p:stCondLst>
+                                        </p:cTn>
+                                        <p:tgtEl>
+                                          <p:spTgt spid="3">
+                                            <p:txEl>
+                                              <p:pRg st="7" end="7"/>
+                                            </p:txEl>
+                                          </p:spTgt>
+                                        </p:tgtEl>
+                                        <p:attrNameLst>
+                                          <p:attrName>style.visibility</p:attrName>
+                                        </p:attrNameLst>
+                                      </p:cBhvr>
+                                      <p:to>
+                                        <p:strVal val="visible"/>
+                                      </p:to>
+                                    </p:set>
+                                  </p:childTnLst>
+                                </p:cTn>
+                              </p:par>
+                            </p:childTnLst>
+                          </p:cTn>
+                        </p:par>
+                      </p:childTnLst>
+                    </p:cTn>
+                  </p:par>
+                  <p:par>
+                    <p:cTn id="25" fill="hold">
+                      <p:stCondLst>
+                        <p:cond delay="indefinite"/>
+                      </p:stCondLst>
+                      <p:childTnLst>
+                        <p:par>
+                          <p:cTn id="26" fill="hold">
+                            <p:stCondLst>
+                              <p:cond delay="0"/>
+                            </p:stCondLst>
+                            <p:childTnLst>
+                              <p:par>
+                                <p:cTn id="27" presetID="1" presetClass="entr" presetSubtype="0" fill="hold" nodeType="clickEffect">
+                                  <p:stCondLst>
+                                    <p:cond delay="0"/>
+                                  </p:stCondLst>
+                                  <p:childTnLst>
+                                    <p:set>
+                                      <p:cBhvr>
+                                        <p:cTn id="28" dur="1" fill="hold">
+                                          <p:stCondLst>
+                                            <p:cond delay="0"/>
+                                          </p:stCondLst>
+                                        </p:cTn>
+                                        <p:tgtEl>
+                                          <p:spTgt spid="3">
+                                            <p:txEl>
+                                              <p:pRg st="9" end="9"/>
+                                            </p:txEl>
+                                          </p:spTgt>
+                                        </p:tgtEl>
+                                        <p:attrNameLst>
+                                          <p:attrName>style.visibility</p:attrName>
+                                        </p:attrNameLst>
+                                      </p:cBhvr>
+                                      <p:to>
+                                        <p:strVal val="visible"/>
+                                      </p:to>
+                                    </p:set>
+                                  </p:childTnLst>
+                                </p:cTn>
+                              </p:par>
+                            </p:childTnLst>
+                          </p:cTn>
+                        </p:par>
+                      </p:childTnLst>
+                    </p:cTn>
+                  </p:par>
+                  <p:par>
+                    <p:cTn id="29" fill="hold">
+                      <p:stCondLst>
+                        <p:cond delay="indefinite"/>
+                      </p:stCondLst>
+                      <p:childTnLst>
+                        <p:par>
+                          <p:cTn id="30" fill="hold">
+                            <p:stCondLst>
+                              <p:cond delay="0"/>
+                            </p:stCondLst>
+                            <p:childTnLst>
+                              <p:par>
+                                <p:cTn id="31" presetID="1" presetClass="entr" presetSubtype="0" fill="hold" nodeType="clickEffect">
+                                  <p:stCondLst>
+                                    <p:cond delay="0"/>
+                                  </p:stCondLst>
+                                  <p:childTnLst>
+                                    <p:set>
+                                      <p:cBhvr>
+                                        <p:cTn id="32" dur="1" fill="hold">
+                                          <p:stCondLst>
+                                            <p:cond delay="0"/>
+                                          </p:stCondLst>
+                                        </p:cTn>
+                                        <p:tgtEl>
+                                          <p:spTgt spid="3">
+                                            <p:txEl>
+                                              <p:pRg st="11" end="11"/>
                                             </p:txEl>
                                           </p:spTgt>
                                         </p:tgtEl>
@@ -3508,6 +3664,160 @@
 </p:sld>
 </file>
 
+<file path=ppt/slides/slide2.xml><?xml version="1.0" encoding="utf-8"?>
+<p:sld xmlns:a="http://schemas.openxmlformats.org/drawingml/2006/main" xmlns:r="http://schemas.openxmlformats.org/officeDocument/2006/relationships" xmlns:p="http://schemas.openxmlformats.org/presentationml/2006/main">
+  <p:cSld>
+    <p:spTree>
+      <p:nvGrpSpPr>
+        <p:cNvPr id="1" name=""/>
+        <p:cNvGrpSpPr/>
+        <p:nvPr/>
+      </p:nvGrpSpPr>
+      <p:grpSpPr/>
+      <p:sp>
+        <p:nvSpPr>
+          <p:cNvPr id="2" name="Title 1"/>
+          <p:cNvSpPr>
+            <a:spLocks noGrp="1"/>
+          </p:cNvSpPr>
+          <p:nvPr>
+            <p:ph type="title"/>
+            <p:custDataLst>
+              <p:tags r:id="rId1"/>
+            </p:custDataLst>
+          </p:nvPr>
+        </p:nvSpPr>
+        <p:spPr/>
+        <p:txBody>
+          <a:bodyPr/>
+          <a:p>
+            <a:r>
+              <a:rPr lang="en-US">
+                <a:sym typeface="+mn-ea"/>
+              </a:rPr>
+              <a:t>Gitgub Repo</a:t>
+            </a:r>
+            <a:endParaRPr lang="en-US"/>
+          </a:p>
+        </p:txBody>
+      </p:sp>
+      <p:sp>
+        <p:nvSpPr>
+          <p:cNvPr id="3" name="Content Placeholder 2"/>
+          <p:cNvSpPr>
+            <a:spLocks noGrp="1"/>
+          </p:cNvSpPr>
+          <p:nvPr>
+            <p:ph idx="1"/>
+            <p:custDataLst>
+              <p:tags r:id="rId2"/>
+            </p:custDataLst>
+          </p:nvPr>
+        </p:nvSpPr>
+        <p:spPr>
+          <a:xfrm>
+            <a:off x="608330" y="1273175"/>
+            <a:ext cx="11423650" cy="941070"/>
+          </a:xfrm>
+        </p:spPr>
+        <p:txBody>
+          <a:bodyPr>
+            <a:noAutofit/>
+          </a:bodyPr>
+          <a:p>
+            <a:pPr marL="0" indent="0">
+              <a:buNone/>
+            </a:pPr>
+            <a:r>
+              <a:rPr lang="en-US" altLang="en-US" sz="3200"/>
+              <a:t>https://github.com/vipar-11/workshop</a:t>
+            </a:r>
+            <a:endParaRPr lang="en-US" altLang="en-US" sz="3200"/>
+          </a:p>
+          <a:p>
+            <a:pPr marL="0" indent="0">
+              <a:buNone/>
+            </a:pPr>
+            <a:endParaRPr lang="en-US" altLang="en-US" sz="3200"/>
+          </a:p>
+        </p:txBody>
+      </p:sp>
+      <p:pic>
+        <p:nvPicPr>
+          <p:cNvPr id="4" name="Picture 3" descr="Screenshot 2026-07-17 at 8.43.33 AM"/>
+          <p:cNvPicPr>
+            <a:picLocks noChangeAspect="1"/>
+          </p:cNvPicPr>
+          <p:nvPr/>
+        </p:nvPicPr>
+        <p:blipFill>
+          <a:blip r:embed="rId3"/>
+          <a:stretch>
+            <a:fillRect/>
+          </a:stretch>
+        </p:blipFill>
+        <p:spPr>
+          <a:xfrm>
+            <a:off x="453390" y="2143760"/>
+            <a:ext cx="11278235" cy="1538605"/>
+          </a:xfrm>
+          <a:prstGeom prst="rect">
+            <a:avLst/>
+          </a:prstGeom>
+          <a:ln>
+            <a:solidFill>
+              <a:schemeClr val="tx1"/>
+            </a:solidFill>
+          </a:ln>
+        </p:spPr>
+      </p:pic>
+      <p:pic>
+        <p:nvPicPr>
+          <p:cNvPr id="5" name="Picture 4" descr="Screenshot 2026-07-17 at 8.45.04 AM"/>
+          <p:cNvPicPr>
+            <a:picLocks noChangeAspect="1"/>
+          </p:cNvPicPr>
+          <p:nvPr/>
+        </p:nvPicPr>
+        <p:blipFill>
+          <a:blip r:embed="rId4"/>
+          <a:stretch>
+            <a:fillRect/>
+          </a:stretch>
+        </p:blipFill>
+        <p:spPr>
+          <a:xfrm>
+            <a:off x="453390" y="3839845"/>
+            <a:ext cx="7357110" cy="2886075"/>
+          </a:xfrm>
+          <a:prstGeom prst="rect">
+            <a:avLst/>
+          </a:prstGeom>
+          <a:ln>
+            <a:solidFill>
+              <a:schemeClr val="tx1"/>
+            </a:solidFill>
+          </a:ln>
+        </p:spPr>
+      </p:pic>
+    </p:spTree>
+    <p:custDataLst>
+      <p:tags r:id="rId5"/>
+    </p:custDataLst>
+  </p:cSld>
+  <p:clrMapOvr>
+    <a:masterClrMapping/>
+  </p:clrMapOvr>
+  <p:timing>
+    <p:tnLst>
+      <p:par>
+        <p:cTn id="1" dur="indefinite" restart="never" nodeType="tmRoot"/>
+      </p:par>
+    </p:tnLst>
+  </p:timing>
+</p:sld>
+</file>
+
 <file path=ppt/tags/tag1.xml><?xml version="1.0" encoding="utf-8"?>
 <p:tagLst xmlns:p="http://schemas.openxmlformats.org/presentationml/2006/main">
   <p:tag name="KSO_WM_UNIT_HIGHLIGHT" val="0"/>
@@ -4306,6 +4616,39 @@
 </file>
 
 <file path=ppt/tags/tag65.xml><?xml version="1.0" encoding="utf-8"?>
+<p:tagLst xmlns:p="http://schemas.openxmlformats.org/presentationml/2006/main">
+  <p:tag name="KSO_WM_BEAUTIFY_FLAG" val="#wm#"/>
+  <p:tag name="KSO_WM_TEMPLATE_CATEGORY" val="custom"/>
+  <p:tag name="KSO_WM_TEMPLATE_INDEX" val="20205081"/>
+</p:tagLst>
+</file>
+
+<file path=ppt/tags/tag66.xml><?xml version="1.0" encoding="utf-8"?>
+<p:tagLst xmlns:p="http://schemas.openxmlformats.org/presentationml/2006/main">
+  <p:tag name="KSO_WM_UNIT_HIGHLIGHT" val="0"/>
+  <p:tag name="KSO_WM_UNIT_COMPATIBLE" val="0"/>
+  <p:tag name="KSO_WM_UNIT_DIAGRAM_ISNUMVISUAL" val="0"/>
+  <p:tag name="KSO_WM_UNIT_DIAGRAM_ISREFERUNIT" val="0"/>
+  <p:tag name="KSO_WM_UNIT_ID" val="_2**"/>
+  <p:tag name="KSO_WM_UNIT_LAYERLEVEL" val="1"/>
+  <p:tag name="KSO_WM_TAG_VERSION" val="1.0"/>
+  <p:tag name="KSO_WM_BEAUTIFY_FLAG" val="#wm#"/>
+</p:tagLst>
+</file>
+
+<file path=ppt/tags/tag67.xml><?xml version="1.0" encoding="utf-8"?>
+<p:tagLst xmlns:p="http://schemas.openxmlformats.org/presentationml/2006/main">
+  <p:tag name="KSO_WM_UNIT_HIGHLIGHT" val="0"/>
+  <p:tag name="KSO_WM_UNIT_COMPATIBLE" val="0"/>
+  <p:tag name="KSO_WM_UNIT_DIAGRAM_ISNUMVISUAL" val="0"/>
+  <p:tag name="KSO_WM_UNIT_DIAGRAM_ISREFERUNIT" val="0"/>
+  <p:tag name="KSO_WM_UNIT_ID" val="_2**"/>
+  <p:tag name="KSO_WM_UNIT_LAYERLEVEL" val="1"/>
+  <p:tag name="KSO_WM_TAG_VERSION" val="1.0"/>
+</p:tagLst>
+</file>
+
+<file path=ppt/tags/tag68.xml><?xml version="1.0" encoding="utf-8"?>
 <p:tagLst xmlns:p="http://schemas.openxmlformats.org/presentationml/2006/main">
   <p:tag name="KSO_WM_BEAUTIFY_FLAG" val="#wm#"/>
   <p:tag name="KSO_WM_TEMPLATE_CATEGORY" val="custom"/>

</xml_diff>